<commit_message>
Publish collapsed batch queue and Harvard analysis credits
</commit_message>
<xml_diff>
--- a/site/showcase/exports/animal_portrait.pptx
+++ b/site/showcase/exports/animal_portrait.pptx
@@ -23,6 +23,7 @@
     <p:sldId id="271" r:id="rId23"/>
     <p:sldId id="272" r:id="rId24"/>
     <p:sldId id="273" r:id="rId25"/>
+    <p:sldId id="274" r:id="rId26"/>
   </p:sldIdLst>
   <p:sldSz cx="9144000" cy="6858000" type="screen4x3"/>
   <p:notesSz cx="6858000" cy="9144000"/>
@@ -1695,6 +1696,101 @@
 </file>
 
 <file path=ppt/notesSlides/notesSlide18.xml><?xml version="1.0" encoding="utf-8"?>
+<p:notes xmlns:a="http://schemas.openxmlformats.org/drawingml/2006/main" xmlns:p="http://schemas.openxmlformats.org/presentationml/2006/main" xmlns:r="http://schemas.openxmlformats.org/officeDocument/2006/relationships">
+  <p:cSld>
+    <p:spTree>
+      <p:nvGrpSpPr>
+        <p:cNvPr id="1" name=""/>
+        <p:cNvGrpSpPr/>
+        <p:nvPr/>
+      </p:nvGrpSpPr>
+      <p:grpSpPr>
+        <a:xfrm>
+          <a:off x="0" y="0"/>
+          <a:ext cx="0" cy="0"/>
+          <a:chOff x="0" y="0"/>
+          <a:chExt cx="0" cy="0"/>
+        </a:xfrm>
+      </p:grpSpPr>
+      <p:sp>
+        <p:nvSpPr>
+          <p:cNvPr id="2" name="Slide Image Placeholder 1"/>
+          <p:cNvSpPr>
+            <a:spLocks noGrp="1"/>
+          </p:cNvSpPr>
+          <p:nvPr>
+            <p:ph type="sldImg" idx="2"/>
+          </p:nvPr>
+        </p:nvSpPr>
+        <p:spPr/>
+      </p:sp>
+      <p:sp>
+        <p:nvSpPr>
+          <p:cNvPr id="3" name="Notes Placeholder 2"/>
+          <p:cNvSpPr>
+            <a:spLocks noGrp="1"/>
+          </p:cNvSpPr>
+          <p:nvPr>
+            <p:ph type="body" idx="3" sz="quarter"/>
+          </p:nvPr>
+        </p:nvSpPr>
+        <p:spPr/>
+        <p:txBody>
+          <a:bodyPr/>
+          <a:lstStyle/>
+          <a:p>
+            <a:r>
+              <a:t>animal-portrait.jpg</a:t>
+            </a:r>
+          </a:p>
+          <a:p>
+            <a:r>
+              <a:t>Cite this analysis</a:t>
+            </a:r>
+          </a:p>
+          <a:p>
+            <a:r>
+              <a:t>Software (Harvard) | Martin, S. (2026) SDA Vision: Synthetic-media Discourse Analysis (version 0.1.0) [Computer software]. Manchester Metropolitan University. Available at: https://sdavision.io/</a:t>
+            </a:r>
+          </a:p>
+          <a:p>
+            <a:r>
+              <a:t>Software creator | Dr Sam Martin, Smart Data Research UK (UKRI) Fellow, Manchester Metropolitan University (MMU). ORCID: https://orcid.org/0000-0002-4466-8374.</a:t>
+            </a:r>
+          </a:p>
+          <a:p>
+            <a:r>
+              <a:t>Funding acknowledgement | This work was supported by Smart Data Research UK, a UKRI investment; Grant number UKRI4010.</a:t>
+            </a:r>
+          </a:p>
+          <a:p>
+            <a:r>
+              <a:t>Analysis record | File: animal-portrait.jpg; media type: image; recorded at: 2026-09-26T22:31:02+00:00; models: claude-opus-5-5, gemini-3.8-flash, gpt-6-astra.</a:t>
+            </a:r>
+          </a:p>
+        </p:txBody>
+      </p:sp>
+      <p:sp>
+        <p:nvSpPr>
+          <p:cNvPr id="4" name="Slide Number Placeholder 3"/>
+          <p:cNvSpPr>
+            <a:spLocks noGrp="1"/>
+          </p:cNvSpPr>
+          <p:nvPr>
+            <p:ph type="sldNum" idx="5" sz="quarter"/>
+          </p:nvPr>
+        </p:nvSpPr>
+        <p:spPr/>
+      </p:sp>
+    </p:spTree>
+  </p:cSld>
+  <p:clrMapOvr>
+    <a:masterClrMapping/>
+  </p:clrMapOvr>
+</p:notes>
+</file>
+
+<file path=ppt/notesSlides/notesSlide19.xml><?xml version="1.0" encoding="utf-8"?>
 <p:notes xmlns:a="http://schemas.openxmlformats.org/drawingml/2006/main" xmlns:p="http://schemas.openxmlformats.org/presentationml/2006/main" xmlns:r="http://schemas.openxmlformats.org/officeDocument/2006/relationships">
   <p:cSld>
     <p:spTree>
@@ -12991,7 +13087,7 @@
               </a:defRPr>
             </a:pPr>
             <a:r>
-              <a:t>File and analysis record</a:t>
+              <a:t>Cite this analysis</a:t>
             </a:r>
           </a:p>
         </p:txBody>
@@ -13076,6 +13172,746 @@
             </a:pPr>
             <a:r>
               <a:t>18</a:t>
+            </a:r>
+          </a:p>
+        </p:txBody>
+      </p:sp>
+      <p:graphicFrame>
+        <p:nvGraphicFramePr>
+          <p:cNvPr id="6" name="Table 5"/>
+          <p:cNvGraphicFramePr>
+            <a:graphicFrameLocks noGrp="1"/>
+          </p:cNvGraphicFramePr>
+          <p:nvPr/>
+        </p:nvGraphicFramePr>
+        <p:xfrm>
+          <a:off x="365760" y="1353312"/>
+          <a:ext cx="8412479" cy="347472"/>
+        </p:xfrm>
+        <a:graphic>
+          <a:graphicData uri="http://schemas.openxmlformats.org/drawingml/2006/table">
+            <a:tbl>
+              <a:tblPr firstRow="1" bandRow="1">
+                <a:tableStyleId>{5C22544A-7EE6-4342-B048-85BDC9FD1C3A}</a:tableStyleId>
+              </a:tblPr>
+              <a:tblGrid>
+                <a:gridCol w="2271369"/>
+                <a:gridCol w="6141110"/>
+              </a:tblGrid>
+              <a:tr h="347472">
+                <a:tc>
+                  <a:txBody>
+                    <a:bodyPr wrap="none"/>
+                    <a:lstStyle/>
+                    <a:p>
+                      <a:pPr>
+                        <a:lnSpc>
+                          <a:spcPts val="1600"/>
+                        </a:lnSpc>
+                        <a:spcAft>
+                          <a:spcPts val="0"/>
+                        </a:spcAft>
+                        <a:defRPr sz="1200" b="1">
+                          <a:solidFill>
+                            <a:srgbClr val="FFFFFF"/>
+                          </a:solidFill>
+                          <a:latin typeface="Arial"/>
+                        </a:defRPr>
+                      </a:pPr>
+                      <a:r>
+                        <a:t>Field</a:t>
+                      </a:r>
+                    </a:p>
+                  </a:txBody>
+                  <a:tcPr marL="82296" marR="82296" marT="64008" marB="64008">
+                    <a:solidFill>
+                      <a:srgbClr val="16787C"/>
+                    </a:solidFill>
+                  </a:tcPr>
+                </a:tc>
+                <a:tc>
+                  <a:txBody>
+                    <a:bodyPr wrap="none"/>
+                    <a:lstStyle/>
+                    <a:p>
+                      <a:pPr>
+                        <a:lnSpc>
+                          <a:spcPts val="1600"/>
+                        </a:lnSpc>
+                        <a:spcAft>
+                          <a:spcPts val="0"/>
+                        </a:spcAft>
+                        <a:defRPr sz="1200" b="1">
+                          <a:solidFill>
+                            <a:srgbClr val="FFFFFF"/>
+                          </a:solidFill>
+                          <a:latin typeface="Arial"/>
+                        </a:defRPr>
+                      </a:pPr>
+                      <a:r>
+                        <a:t>Recorded detail</a:t>
+                      </a:r>
+                    </a:p>
+                  </a:txBody>
+                  <a:tcPr marL="82296" marR="82296" marT="64008" marB="64008">
+                    <a:solidFill>
+                      <a:srgbClr val="16787C"/>
+                    </a:solidFill>
+                  </a:tcPr>
+                </a:tc>
+              </a:tr>
+            </a:tbl>
+          </a:graphicData>
+        </a:graphic>
+      </p:graphicFrame>
+      <p:graphicFrame>
+        <p:nvGraphicFramePr>
+          <p:cNvPr id="7" name="Table 6"/>
+          <p:cNvGraphicFramePr>
+            <a:graphicFrameLocks noGrp="1"/>
+          </p:cNvGraphicFramePr>
+          <p:nvPr/>
+        </p:nvGraphicFramePr>
+        <p:xfrm>
+          <a:off x="365760" y="1700784"/>
+          <a:ext cx="8412479" cy="755904"/>
+        </p:xfrm>
+        <a:graphic>
+          <a:graphicData uri="http://schemas.openxmlformats.org/drawingml/2006/table">
+            <a:tbl>
+              <a:tblPr firstRow="1" bandRow="1">
+                <a:tableStyleId>{5C22544A-7EE6-4342-B048-85BDC9FD1C3A}</a:tableStyleId>
+              </a:tblPr>
+              <a:tblGrid>
+                <a:gridCol w="2271369"/>
+                <a:gridCol w="6141110"/>
+              </a:tblGrid>
+              <a:tr h="755904">
+                <a:tc>
+                  <a:txBody>
+                    <a:bodyPr wrap="none"/>
+                    <a:lstStyle/>
+                    <a:p>
+                      <a:pPr>
+                        <a:lnSpc>
+                          <a:spcPts val="1600"/>
+                        </a:lnSpc>
+                        <a:spcAft>
+                          <a:spcPts val="0"/>
+                        </a:spcAft>
+                        <a:defRPr sz="1200" b="0">
+                          <a:solidFill>
+                            <a:srgbClr val="21243A"/>
+                          </a:solidFill>
+                          <a:latin typeface="Arial"/>
+                        </a:defRPr>
+                      </a:pPr>
+                      <a:r>
+                        <a:t>Software (Harvard)</a:t>
+                      </a:r>
+                    </a:p>
+                  </a:txBody>
+                  <a:tcPr marL="82296" marR="82296" marT="64008" marB="64008">
+                    <a:solidFill>
+                      <a:srgbClr val="F1F7F7"/>
+                    </a:solidFill>
+                  </a:tcPr>
+                </a:tc>
+                <a:tc>
+                  <a:txBody>
+                    <a:bodyPr wrap="none"/>
+                    <a:lstStyle/>
+                    <a:p>
+                      <a:pPr>
+                        <a:lnSpc>
+                          <a:spcPts val="1600"/>
+                        </a:lnSpc>
+                        <a:spcAft>
+                          <a:spcPts val="0"/>
+                        </a:spcAft>
+                        <a:defRPr sz="1200" b="0">
+                          <a:solidFill>
+                            <a:srgbClr val="21243A"/>
+                          </a:solidFill>
+                          <a:latin typeface="Arial"/>
+                        </a:defRPr>
+                      </a:pPr>
+                      <a:r>
+                        <a:t>Martin, S. (2026) SDA Vision: Synthetic-media Discourse Analysis (version 0.1.0)</a:t>
+                      </a:r>
+                    </a:p>
+                    <a:p>
+                      <a:pPr>
+                        <a:lnSpc>
+                          <a:spcPts val="1600"/>
+                        </a:lnSpc>
+                        <a:spcAft>
+                          <a:spcPts val="0"/>
+                        </a:spcAft>
+                        <a:defRPr sz="1200" b="0">
+                          <a:solidFill>
+                            <a:srgbClr val="21243A"/>
+                          </a:solidFill>
+                          <a:latin typeface="Arial"/>
+                        </a:defRPr>
+                      </a:pPr>
+                      <a:r>
+                        <a:t>[Computer software]. Manchester Metropolitan University. Available at:</a:t>
+                      </a:r>
+                    </a:p>
+                    <a:p>
+                      <a:pPr>
+                        <a:lnSpc>
+                          <a:spcPts val="1600"/>
+                        </a:lnSpc>
+                        <a:spcAft>
+                          <a:spcPts val="0"/>
+                        </a:spcAft>
+                        <a:defRPr sz="1200" b="0">
+                          <a:solidFill>
+                            <a:srgbClr val="21243A"/>
+                          </a:solidFill>
+                          <a:latin typeface="Arial"/>
+                        </a:defRPr>
+                      </a:pPr>
+                      <a:r>
+                        <a:t>https://sdavision.io/</a:t>
+                      </a:r>
+                    </a:p>
+                  </a:txBody>
+                  <a:tcPr marL="82296" marR="82296" marT="64008" marB="64008">
+                    <a:solidFill>
+                      <a:srgbClr val="F1F7F7"/>
+                    </a:solidFill>
+                  </a:tcPr>
+                </a:tc>
+              </a:tr>
+            </a:tbl>
+          </a:graphicData>
+        </a:graphic>
+      </p:graphicFrame>
+      <p:graphicFrame>
+        <p:nvGraphicFramePr>
+          <p:cNvPr id="8" name="Table 7"/>
+          <p:cNvGraphicFramePr>
+            <a:graphicFrameLocks noGrp="1"/>
+          </p:cNvGraphicFramePr>
+          <p:nvPr/>
+        </p:nvGraphicFramePr>
+        <p:xfrm>
+          <a:off x="365760" y="2456688"/>
+          <a:ext cx="8412479" cy="552704"/>
+        </p:xfrm>
+        <a:graphic>
+          <a:graphicData uri="http://schemas.openxmlformats.org/drawingml/2006/table">
+            <a:tbl>
+              <a:tblPr firstRow="1" bandRow="1">
+                <a:tableStyleId>{5C22544A-7EE6-4342-B048-85BDC9FD1C3A}</a:tableStyleId>
+              </a:tblPr>
+              <a:tblGrid>
+                <a:gridCol w="2271369"/>
+                <a:gridCol w="6141110"/>
+              </a:tblGrid>
+              <a:tr h="552704">
+                <a:tc>
+                  <a:txBody>
+                    <a:bodyPr wrap="none"/>
+                    <a:lstStyle/>
+                    <a:p>
+                      <a:pPr>
+                        <a:lnSpc>
+                          <a:spcPts val="1600"/>
+                        </a:lnSpc>
+                        <a:spcAft>
+                          <a:spcPts val="0"/>
+                        </a:spcAft>
+                        <a:defRPr sz="1200" b="0">
+                          <a:solidFill>
+                            <a:srgbClr val="21243A"/>
+                          </a:solidFill>
+                          <a:latin typeface="Arial"/>
+                        </a:defRPr>
+                      </a:pPr>
+                      <a:r>
+                        <a:t>Software creator</a:t>
+                      </a:r>
+                    </a:p>
+                  </a:txBody>
+                  <a:tcPr marL="82296" marR="82296" marT="64008" marB="64008">
+                    <a:solidFill>
+                      <a:srgbClr val="FFFFFF"/>
+                    </a:solidFill>
+                  </a:tcPr>
+                </a:tc>
+                <a:tc>
+                  <a:txBody>
+                    <a:bodyPr wrap="none"/>
+                    <a:lstStyle/>
+                    <a:p>
+                      <a:pPr>
+                        <a:lnSpc>
+                          <a:spcPts val="1600"/>
+                        </a:lnSpc>
+                        <a:spcAft>
+                          <a:spcPts val="0"/>
+                        </a:spcAft>
+                        <a:defRPr sz="1200" b="0">
+                          <a:solidFill>
+                            <a:srgbClr val="21243A"/>
+                          </a:solidFill>
+                          <a:latin typeface="Arial"/>
+                        </a:defRPr>
+                      </a:pPr>
+                      <a:r>
+                        <a:t>Dr Sam Martin, Smart Data Research UK (UKRI) Fellow, Manchester Metropolitan</a:t>
+                      </a:r>
+                    </a:p>
+                    <a:p>
+                      <a:pPr>
+                        <a:lnSpc>
+                          <a:spcPts val="1600"/>
+                        </a:lnSpc>
+                        <a:spcAft>
+                          <a:spcPts val="0"/>
+                        </a:spcAft>
+                        <a:defRPr sz="1200" b="0">
+                          <a:solidFill>
+                            <a:srgbClr val="21243A"/>
+                          </a:solidFill>
+                          <a:latin typeface="Arial"/>
+                        </a:defRPr>
+                      </a:pPr>
+                      <a:r>
+                        <a:t>University (MMU). ORCID: https://orcid.org/0000-0002-4466-8374.</a:t>
+                      </a:r>
+                    </a:p>
+                  </a:txBody>
+                  <a:tcPr marL="82296" marR="82296" marT="64008" marB="64008">
+                    <a:solidFill>
+                      <a:srgbClr val="FFFFFF"/>
+                    </a:solidFill>
+                  </a:tcPr>
+                </a:tc>
+              </a:tr>
+            </a:tbl>
+          </a:graphicData>
+        </a:graphic>
+      </p:graphicFrame>
+      <p:graphicFrame>
+        <p:nvGraphicFramePr>
+          <p:cNvPr id="9" name="Table 8"/>
+          <p:cNvGraphicFramePr>
+            <a:graphicFrameLocks noGrp="1"/>
+          </p:cNvGraphicFramePr>
+          <p:nvPr/>
+        </p:nvGraphicFramePr>
+        <p:xfrm>
+          <a:off x="365760" y="3009392"/>
+          <a:ext cx="8412479" cy="552704"/>
+        </p:xfrm>
+        <a:graphic>
+          <a:graphicData uri="http://schemas.openxmlformats.org/drawingml/2006/table">
+            <a:tbl>
+              <a:tblPr firstRow="1" bandRow="1">
+                <a:tableStyleId>{5C22544A-7EE6-4342-B048-85BDC9FD1C3A}</a:tableStyleId>
+              </a:tblPr>
+              <a:tblGrid>
+                <a:gridCol w="2271369"/>
+                <a:gridCol w="6141110"/>
+              </a:tblGrid>
+              <a:tr h="552704">
+                <a:tc>
+                  <a:txBody>
+                    <a:bodyPr wrap="none"/>
+                    <a:lstStyle/>
+                    <a:p>
+                      <a:pPr>
+                        <a:lnSpc>
+                          <a:spcPts val="1600"/>
+                        </a:lnSpc>
+                        <a:spcAft>
+                          <a:spcPts val="0"/>
+                        </a:spcAft>
+                        <a:defRPr sz="1200" b="0">
+                          <a:solidFill>
+                            <a:srgbClr val="21243A"/>
+                          </a:solidFill>
+                          <a:latin typeface="Arial"/>
+                        </a:defRPr>
+                      </a:pPr>
+                      <a:r>
+                        <a:t>Funding acknowledgement</a:t>
+                      </a:r>
+                    </a:p>
+                  </a:txBody>
+                  <a:tcPr marL="82296" marR="82296" marT="64008" marB="64008">
+                    <a:solidFill>
+                      <a:srgbClr val="F1F7F7"/>
+                    </a:solidFill>
+                  </a:tcPr>
+                </a:tc>
+                <a:tc>
+                  <a:txBody>
+                    <a:bodyPr wrap="none"/>
+                    <a:lstStyle/>
+                    <a:p>
+                      <a:pPr>
+                        <a:lnSpc>
+                          <a:spcPts val="1600"/>
+                        </a:lnSpc>
+                        <a:spcAft>
+                          <a:spcPts val="0"/>
+                        </a:spcAft>
+                        <a:defRPr sz="1200" b="0">
+                          <a:solidFill>
+                            <a:srgbClr val="21243A"/>
+                          </a:solidFill>
+                          <a:latin typeface="Arial"/>
+                        </a:defRPr>
+                      </a:pPr>
+                      <a:r>
+                        <a:t>This work was supported by Smart Data Research UK, a UKRI investment; Grant</a:t>
+                      </a:r>
+                    </a:p>
+                    <a:p>
+                      <a:pPr>
+                        <a:lnSpc>
+                          <a:spcPts val="1600"/>
+                        </a:lnSpc>
+                        <a:spcAft>
+                          <a:spcPts val="0"/>
+                        </a:spcAft>
+                        <a:defRPr sz="1200" b="0">
+                          <a:solidFill>
+                            <a:srgbClr val="21243A"/>
+                          </a:solidFill>
+                          <a:latin typeface="Arial"/>
+                        </a:defRPr>
+                      </a:pPr>
+                      <a:r>
+                        <a:t>number UKRI4010.</a:t>
+                      </a:r>
+                    </a:p>
+                  </a:txBody>
+                  <a:tcPr marL="82296" marR="82296" marT="64008" marB="64008">
+                    <a:solidFill>
+                      <a:srgbClr val="F1F7F7"/>
+                    </a:solidFill>
+                  </a:tcPr>
+                </a:tc>
+              </a:tr>
+            </a:tbl>
+          </a:graphicData>
+        </a:graphic>
+      </p:graphicFrame>
+      <p:graphicFrame>
+        <p:nvGraphicFramePr>
+          <p:cNvPr id="10" name="Table 9"/>
+          <p:cNvGraphicFramePr>
+            <a:graphicFrameLocks noGrp="1"/>
+          </p:cNvGraphicFramePr>
+          <p:nvPr/>
+        </p:nvGraphicFramePr>
+        <p:xfrm>
+          <a:off x="365760" y="3562095"/>
+          <a:ext cx="8412479" cy="755904"/>
+        </p:xfrm>
+        <a:graphic>
+          <a:graphicData uri="http://schemas.openxmlformats.org/drawingml/2006/table">
+            <a:tbl>
+              <a:tblPr firstRow="1" bandRow="1">
+                <a:tableStyleId>{5C22544A-7EE6-4342-B048-85BDC9FD1C3A}</a:tableStyleId>
+              </a:tblPr>
+              <a:tblGrid>
+                <a:gridCol w="2271369"/>
+                <a:gridCol w="6141110"/>
+              </a:tblGrid>
+              <a:tr h="755904">
+                <a:tc>
+                  <a:txBody>
+                    <a:bodyPr wrap="none"/>
+                    <a:lstStyle/>
+                    <a:p>
+                      <a:pPr>
+                        <a:lnSpc>
+                          <a:spcPts val="1600"/>
+                        </a:lnSpc>
+                        <a:spcAft>
+                          <a:spcPts val="0"/>
+                        </a:spcAft>
+                        <a:defRPr sz="1200" b="0">
+                          <a:solidFill>
+                            <a:srgbClr val="21243A"/>
+                          </a:solidFill>
+                          <a:latin typeface="Arial"/>
+                        </a:defRPr>
+                      </a:pPr>
+                      <a:r>
+                        <a:t>Analysis record</a:t>
+                      </a:r>
+                    </a:p>
+                  </a:txBody>
+                  <a:tcPr marL="82296" marR="82296" marT="64008" marB="64008">
+                    <a:solidFill>
+                      <a:srgbClr val="FFFFFF"/>
+                    </a:solidFill>
+                  </a:tcPr>
+                </a:tc>
+                <a:tc>
+                  <a:txBody>
+                    <a:bodyPr wrap="none"/>
+                    <a:lstStyle/>
+                    <a:p>
+                      <a:pPr>
+                        <a:lnSpc>
+                          <a:spcPts val="1600"/>
+                        </a:lnSpc>
+                        <a:spcAft>
+                          <a:spcPts val="0"/>
+                        </a:spcAft>
+                        <a:defRPr sz="1200" b="0">
+                          <a:solidFill>
+                            <a:srgbClr val="21243A"/>
+                          </a:solidFill>
+                          <a:latin typeface="Arial"/>
+                        </a:defRPr>
+                      </a:pPr>
+                      <a:r>
+                        <a:t>File: animal-portrait.jpg; media type: image; recorded at:</a:t>
+                      </a:r>
+                    </a:p>
+                    <a:p>
+                      <a:pPr>
+                        <a:lnSpc>
+                          <a:spcPts val="1600"/>
+                        </a:lnSpc>
+                        <a:spcAft>
+                          <a:spcPts val="0"/>
+                        </a:spcAft>
+                        <a:defRPr sz="1200" b="0">
+                          <a:solidFill>
+                            <a:srgbClr val="21243A"/>
+                          </a:solidFill>
+                          <a:latin typeface="Arial"/>
+                        </a:defRPr>
+                      </a:pPr>
+                      <a:r>
+                        <a:t>2026-09-26T22:31:02+00:00; models: claude-opus-5-5, gemini-3.8-flash,</a:t>
+                      </a:r>
+                    </a:p>
+                    <a:p>
+                      <a:pPr>
+                        <a:lnSpc>
+                          <a:spcPts val="1600"/>
+                        </a:lnSpc>
+                        <a:spcAft>
+                          <a:spcPts val="0"/>
+                        </a:spcAft>
+                        <a:defRPr sz="1200" b="0">
+                          <a:solidFill>
+                            <a:srgbClr val="21243A"/>
+                          </a:solidFill>
+                          <a:latin typeface="Arial"/>
+                        </a:defRPr>
+                      </a:pPr>
+                      <a:r>
+                        <a:t>gpt-6-astra.</a:t>
+                      </a:r>
+                    </a:p>
+                  </a:txBody>
+                  <a:tcPr marL="82296" marR="82296" marT="64008" marB="64008">
+                    <a:solidFill>
+                      <a:srgbClr val="FFFFFF"/>
+                    </a:solidFill>
+                  </a:tcPr>
+                </a:tc>
+              </a:tr>
+            </a:tbl>
+          </a:graphicData>
+        </a:graphic>
+      </p:graphicFrame>
+    </p:spTree>
+  </p:cSld>
+  <p:clrMapOvr>
+    <a:masterClrMapping/>
+  </p:clrMapOvr>
+</p:sld>
+</file>
+
+<file path=ppt/slides/slide19.xml><?xml version="1.0" encoding="utf-8"?>
+<p:sld xmlns:a="http://schemas.openxmlformats.org/drawingml/2006/main" xmlns:p="http://schemas.openxmlformats.org/presentationml/2006/main" xmlns:r="http://schemas.openxmlformats.org/officeDocument/2006/relationships">
+  <p:cSld>
+    <p:spTree>
+      <p:nvGrpSpPr>
+        <p:cNvPr id="1" name=""/>
+        <p:cNvGrpSpPr/>
+        <p:nvPr/>
+      </p:nvGrpSpPr>
+      <p:grpSpPr/>
+      <p:sp>
+        <p:nvSpPr>
+          <p:cNvPr id="2" name="TextBox 1"/>
+          <p:cNvSpPr txBox="1"/>
+          <p:nvPr/>
+        </p:nvSpPr>
+        <p:spPr>
+          <a:xfrm>
+            <a:off x="365760" y="219456"/>
+            <a:ext cx="8412480" cy="228600"/>
+          </a:xfrm>
+          <a:prstGeom prst="rect">
+            <a:avLst/>
+          </a:prstGeom>
+          <a:noFill/>
+        </p:spPr>
+        <p:txBody>
+          <a:bodyPr wrap="square" lIns="0" rIns="0" tIns="0" bIns="0">
+            <a:spAutoFit/>
+          </a:bodyPr>
+          <a:lstStyle/>
+          <a:p>
+            <a:pPr>
+              <a:lnSpc>
+                <a:spcPct val="115000"/>
+              </a:lnSpc>
+              <a:spcAft>
+                <a:spcPts val="0"/>
+              </a:spcAft>
+              <a:defRPr sz="1100" b="1">
+                <a:solidFill>
+                  <a:srgbClr val="C5006A"/>
+                </a:solidFill>
+                <a:latin typeface="Arial"/>
+              </a:defRPr>
+            </a:pPr>
+            <a:r>
+              <a:t>SDA VISION / RESEARCH REPORT</a:t>
+            </a:r>
+          </a:p>
+        </p:txBody>
+      </p:sp>
+      <p:sp>
+        <p:nvSpPr>
+          <p:cNvPr id="3" name="TextBox 2"/>
+          <p:cNvSpPr txBox="1"/>
+          <p:nvPr/>
+        </p:nvSpPr>
+        <p:spPr>
+          <a:xfrm>
+            <a:off x="365760" y="658368"/>
+            <a:ext cx="8412480" cy="612648"/>
+          </a:xfrm>
+          <a:prstGeom prst="rect">
+            <a:avLst/>
+          </a:prstGeom>
+          <a:noFill/>
+        </p:spPr>
+        <p:txBody>
+          <a:bodyPr wrap="square" lIns="0" rIns="0" tIns="0" bIns="0">
+            <a:spAutoFit/>
+          </a:bodyPr>
+          <a:lstStyle/>
+          <a:p>
+            <a:pPr>
+              <a:lnSpc>
+                <a:spcPct val="115000"/>
+              </a:lnSpc>
+              <a:spcAft>
+                <a:spcPts val="0"/>
+              </a:spcAft>
+              <a:defRPr sz="2200" b="1">
+                <a:solidFill>
+                  <a:srgbClr val="21243A"/>
+                </a:solidFill>
+                <a:latin typeface="Arial"/>
+              </a:defRPr>
+            </a:pPr>
+            <a:r>
+              <a:t>File and analysis record</a:t>
+            </a:r>
+          </a:p>
+        </p:txBody>
+      </p:sp>
+      <p:sp>
+        <p:nvSpPr>
+          <p:cNvPr id="4" name="TextBox 3"/>
+          <p:cNvSpPr txBox="1"/>
+          <p:nvPr/>
+        </p:nvSpPr>
+        <p:spPr>
+          <a:xfrm>
+            <a:off x="365760" y="6291072"/>
+            <a:ext cx="8001000" cy="365760"/>
+          </a:xfrm>
+          <a:prstGeom prst="rect">
+            <a:avLst/>
+          </a:prstGeom>
+          <a:noFill/>
+        </p:spPr>
+        <p:txBody>
+          <a:bodyPr wrap="square" lIns="0" rIns="0" tIns="0" bIns="0">
+            <a:spAutoFit/>
+          </a:bodyPr>
+          <a:lstStyle/>
+          <a:p>
+            <a:pPr>
+              <a:lnSpc>
+                <a:spcPct val="115000"/>
+              </a:lnSpc>
+              <a:spcAft>
+                <a:spcPts val="0"/>
+              </a:spcAft>
+              <a:defRPr sz="800" b="0">
+                <a:solidFill>
+                  <a:srgbClr val="545B6D"/>
+                </a:solidFill>
+                <a:latin typeface="Arial"/>
+              </a:defRPr>
+            </a:pPr>
+            <a:r>
+              <a:t>Research assessment. Ratings are not calibrated probabilities.</a:t>
+            </a:r>
+          </a:p>
+        </p:txBody>
+      </p:sp>
+      <p:sp>
+        <p:nvSpPr>
+          <p:cNvPr id="5" name="TextBox 4"/>
+          <p:cNvSpPr txBox="1"/>
+          <p:nvPr/>
+        </p:nvSpPr>
+        <p:spPr>
+          <a:xfrm>
+            <a:off x="8394192" y="6318504"/>
+            <a:ext cx="365760" cy="228600"/>
+          </a:xfrm>
+          <a:prstGeom prst="rect">
+            <a:avLst/>
+          </a:prstGeom>
+          <a:noFill/>
+        </p:spPr>
+        <p:txBody>
+          <a:bodyPr wrap="square" lIns="0" rIns="0" tIns="0" bIns="0">
+            <a:spAutoFit/>
+          </a:bodyPr>
+          <a:lstStyle/>
+          <a:p>
+            <a:pPr>
+              <a:lnSpc>
+                <a:spcPct val="115000"/>
+              </a:lnSpc>
+              <a:spcAft>
+                <a:spcPts val="0"/>
+              </a:spcAft>
+              <a:defRPr sz="900" b="0">
+                <a:solidFill>
+                  <a:srgbClr val="545B6D"/>
+                </a:solidFill>
+                <a:latin typeface="Arial"/>
+              </a:defRPr>
+            </a:pPr>
+            <a:r>
+              <a:t>19</a:t>
             </a:r>
           </a:p>
         </p:txBody>

</xml_diff>

<commit_message>
Use Software citation label in demo and reports
</commit_message>
<xml_diff>
--- a/site/showcase/exports/animal_portrait.pptx
+++ b/site/showcase/exports/animal_portrait.pptx
@@ -1750,7 +1750,7 @@
           </a:p>
           <a:p>
             <a:r>
-              <a:t>Software (Harvard) | Martin, S. (2026) SDA Vision: Synthetic-media Discourse Analysis (version 0.1.0) [Computer software]. Manchester Metropolitan University. Available at: https://sdavision.io/</a:t>
+              <a:t>Software citation | Martin, S. (2026) SDA Vision: Synthetic-media Discourse Analysis (version 0.1.0) [Computer software]. Manchester Metropolitan University. Available at: https://sdavision.io/</a:t>
             </a:r>
           </a:p>
           <a:p>
@@ -13307,7 +13307,7 @@
                         </a:defRPr>
                       </a:pPr>
                       <a:r>
-                        <a:t>Software (Harvard)</a:t>
+                        <a:t>Software citation</a:t>
                       </a:r>
                     </a:p>
                   </a:txBody>

</xml_diff>

<commit_message>
Publish SDA Vision 0.1.3 and guides 1.7 on existing hosting
</commit_message>
<xml_diff>
--- a/site/showcase/exports/animal_portrait.pptx
+++ b/site/showcase/exports/animal_portrait.pptx
@@ -23,7 +23,6 @@
     <p:sldId id="271" r:id="rId23"/>
     <p:sldId id="272" r:id="rId24"/>
     <p:sldId id="273" r:id="rId25"/>
-    <p:sldId id="274" r:id="rId26"/>
   </p:sldIdLst>
   <p:sldSz cx="9144000" cy="6858000" type="screen4x3"/>
   <p:notesSz cx="6858000" cy="9144000"/>
@@ -1696,101 +1695,6 @@
 </file>
 
 <file path=ppt/notesSlides/notesSlide18.xml><?xml version="1.0" encoding="utf-8"?>
-<p:notes xmlns:a="http://schemas.openxmlformats.org/drawingml/2006/main" xmlns:p="http://schemas.openxmlformats.org/presentationml/2006/main" xmlns:r="http://schemas.openxmlformats.org/officeDocument/2006/relationships">
-  <p:cSld>
-    <p:spTree>
-      <p:nvGrpSpPr>
-        <p:cNvPr id="1" name=""/>
-        <p:cNvGrpSpPr/>
-        <p:nvPr/>
-      </p:nvGrpSpPr>
-      <p:grpSpPr>
-        <a:xfrm>
-          <a:off x="0" y="0"/>
-          <a:ext cx="0" cy="0"/>
-          <a:chOff x="0" y="0"/>
-          <a:chExt cx="0" cy="0"/>
-        </a:xfrm>
-      </p:grpSpPr>
-      <p:sp>
-        <p:nvSpPr>
-          <p:cNvPr id="2" name="Slide Image Placeholder 1"/>
-          <p:cNvSpPr>
-            <a:spLocks noGrp="1"/>
-          </p:cNvSpPr>
-          <p:nvPr>
-            <p:ph type="sldImg" idx="2"/>
-          </p:nvPr>
-        </p:nvSpPr>
-        <p:spPr/>
-      </p:sp>
-      <p:sp>
-        <p:nvSpPr>
-          <p:cNvPr id="3" name="Notes Placeholder 2"/>
-          <p:cNvSpPr>
-            <a:spLocks noGrp="1"/>
-          </p:cNvSpPr>
-          <p:nvPr>
-            <p:ph type="body" idx="3" sz="quarter"/>
-          </p:nvPr>
-        </p:nvSpPr>
-        <p:spPr/>
-        <p:txBody>
-          <a:bodyPr/>
-          <a:lstStyle/>
-          <a:p>
-            <a:r>
-              <a:t>animal-portrait.jpg</a:t>
-            </a:r>
-          </a:p>
-          <a:p>
-            <a:r>
-              <a:t>Cite this analysis</a:t>
-            </a:r>
-          </a:p>
-          <a:p>
-            <a:r>
-              <a:t>Software citation | Martin, S. (2026) SDA Vision: Synthetic-media Discourse Analysis (version 0.1.0) [Computer software]. Manchester Metropolitan University. Available at: https://sdavision.io/</a:t>
-            </a:r>
-          </a:p>
-          <a:p>
-            <a:r>
-              <a:t>Software creator | Dr Sam Martin, Smart Data Research UK (UKRI) Fellow, Manchester Metropolitan University (MMU). ORCID: https://orcid.org/0000-0002-4466-8374.</a:t>
-            </a:r>
-          </a:p>
-          <a:p>
-            <a:r>
-              <a:t>Funding acknowledgement | This work was supported by Smart Data Research UK, a UKRI investment; Grant number UKRI4010.</a:t>
-            </a:r>
-          </a:p>
-          <a:p>
-            <a:r>
-              <a:t>Analysis record | File: animal-portrait.jpg; media type: image; recorded at: 2026-09-26T22:31:02+00:00; models: claude-opus-5-5, gemini-3.8-flash, gpt-6-astra.</a:t>
-            </a:r>
-          </a:p>
-        </p:txBody>
-      </p:sp>
-      <p:sp>
-        <p:nvSpPr>
-          <p:cNvPr id="4" name="Slide Number Placeholder 3"/>
-          <p:cNvSpPr>
-            <a:spLocks noGrp="1"/>
-          </p:cNvSpPr>
-          <p:nvPr>
-            <p:ph type="sldNum" idx="5" sz="quarter"/>
-          </p:nvPr>
-        </p:nvSpPr>
-        <p:spPr/>
-      </p:sp>
-    </p:spTree>
-  </p:cSld>
-  <p:clrMapOvr>
-    <a:masterClrMapping/>
-  </p:clrMapOvr>
-</p:notes>
-</file>
-
-<file path=ppt/notesSlides/notesSlide19.xml><?xml version="1.0" encoding="utf-8"?>
 <p:notes xmlns:a="http://schemas.openxmlformats.org/drawingml/2006/main" xmlns:p="http://schemas.openxmlformats.org/presentationml/2006/main" xmlns:r="http://schemas.openxmlformats.org/officeDocument/2006/relationships">
   <p:cSld>
     <p:spTree>
@@ -13087,7 +12991,7 @@
               </a:defRPr>
             </a:pPr>
             <a:r>
-              <a:t>Cite this analysis</a:t>
+              <a:t>File and analysis record</a:t>
             </a:r>
           </a:p>
         </p:txBody>
@@ -13172,746 +13076,6 @@
             </a:pPr>
             <a:r>
               <a:t>18</a:t>
-            </a:r>
-          </a:p>
-        </p:txBody>
-      </p:sp>
-      <p:graphicFrame>
-        <p:nvGraphicFramePr>
-          <p:cNvPr id="6" name="Table 5"/>
-          <p:cNvGraphicFramePr>
-            <a:graphicFrameLocks noGrp="1"/>
-          </p:cNvGraphicFramePr>
-          <p:nvPr/>
-        </p:nvGraphicFramePr>
-        <p:xfrm>
-          <a:off x="365760" y="1353312"/>
-          <a:ext cx="8412479" cy="347472"/>
-        </p:xfrm>
-        <a:graphic>
-          <a:graphicData uri="http://schemas.openxmlformats.org/drawingml/2006/table">
-            <a:tbl>
-              <a:tblPr firstRow="1" bandRow="1">
-                <a:tableStyleId>{5C22544A-7EE6-4342-B048-85BDC9FD1C3A}</a:tableStyleId>
-              </a:tblPr>
-              <a:tblGrid>
-                <a:gridCol w="2271369"/>
-                <a:gridCol w="6141110"/>
-              </a:tblGrid>
-              <a:tr h="347472">
-                <a:tc>
-                  <a:txBody>
-                    <a:bodyPr wrap="none"/>
-                    <a:lstStyle/>
-                    <a:p>
-                      <a:pPr>
-                        <a:lnSpc>
-                          <a:spcPts val="1600"/>
-                        </a:lnSpc>
-                        <a:spcAft>
-                          <a:spcPts val="0"/>
-                        </a:spcAft>
-                        <a:defRPr sz="1200" b="1">
-                          <a:solidFill>
-                            <a:srgbClr val="FFFFFF"/>
-                          </a:solidFill>
-                          <a:latin typeface="Arial"/>
-                        </a:defRPr>
-                      </a:pPr>
-                      <a:r>
-                        <a:t>Field</a:t>
-                      </a:r>
-                    </a:p>
-                  </a:txBody>
-                  <a:tcPr marL="82296" marR="82296" marT="64008" marB="64008">
-                    <a:solidFill>
-                      <a:srgbClr val="16787C"/>
-                    </a:solidFill>
-                  </a:tcPr>
-                </a:tc>
-                <a:tc>
-                  <a:txBody>
-                    <a:bodyPr wrap="none"/>
-                    <a:lstStyle/>
-                    <a:p>
-                      <a:pPr>
-                        <a:lnSpc>
-                          <a:spcPts val="1600"/>
-                        </a:lnSpc>
-                        <a:spcAft>
-                          <a:spcPts val="0"/>
-                        </a:spcAft>
-                        <a:defRPr sz="1200" b="1">
-                          <a:solidFill>
-                            <a:srgbClr val="FFFFFF"/>
-                          </a:solidFill>
-                          <a:latin typeface="Arial"/>
-                        </a:defRPr>
-                      </a:pPr>
-                      <a:r>
-                        <a:t>Recorded detail</a:t>
-                      </a:r>
-                    </a:p>
-                  </a:txBody>
-                  <a:tcPr marL="82296" marR="82296" marT="64008" marB="64008">
-                    <a:solidFill>
-                      <a:srgbClr val="16787C"/>
-                    </a:solidFill>
-                  </a:tcPr>
-                </a:tc>
-              </a:tr>
-            </a:tbl>
-          </a:graphicData>
-        </a:graphic>
-      </p:graphicFrame>
-      <p:graphicFrame>
-        <p:nvGraphicFramePr>
-          <p:cNvPr id="7" name="Table 6"/>
-          <p:cNvGraphicFramePr>
-            <a:graphicFrameLocks noGrp="1"/>
-          </p:cNvGraphicFramePr>
-          <p:nvPr/>
-        </p:nvGraphicFramePr>
-        <p:xfrm>
-          <a:off x="365760" y="1700784"/>
-          <a:ext cx="8412479" cy="755904"/>
-        </p:xfrm>
-        <a:graphic>
-          <a:graphicData uri="http://schemas.openxmlformats.org/drawingml/2006/table">
-            <a:tbl>
-              <a:tblPr firstRow="1" bandRow="1">
-                <a:tableStyleId>{5C22544A-7EE6-4342-B048-85BDC9FD1C3A}</a:tableStyleId>
-              </a:tblPr>
-              <a:tblGrid>
-                <a:gridCol w="2271369"/>
-                <a:gridCol w="6141110"/>
-              </a:tblGrid>
-              <a:tr h="755904">
-                <a:tc>
-                  <a:txBody>
-                    <a:bodyPr wrap="none"/>
-                    <a:lstStyle/>
-                    <a:p>
-                      <a:pPr>
-                        <a:lnSpc>
-                          <a:spcPts val="1600"/>
-                        </a:lnSpc>
-                        <a:spcAft>
-                          <a:spcPts val="0"/>
-                        </a:spcAft>
-                        <a:defRPr sz="1200" b="0">
-                          <a:solidFill>
-                            <a:srgbClr val="21243A"/>
-                          </a:solidFill>
-                          <a:latin typeface="Arial"/>
-                        </a:defRPr>
-                      </a:pPr>
-                      <a:r>
-                        <a:t>Software citation</a:t>
-                      </a:r>
-                    </a:p>
-                  </a:txBody>
-                  <a:tcPr marL="82296" marR="82296" marT="64008" marB="64008">
-                    <a:solidFill>
-                      <a:srgbClr val="F1F7F7"/>
-                    </a:solidFill>
-                  </a:tcPr>
-                </a:tc>
-                <a:tc>
-                  <a:txBody>
-                    <a:bodyPr wrap="none"/>
-                    <a:lstStyle/>
-                    <a:p>
-                      <a:pPr>
-                        <a:lnSpc>
-                          <a:spcPts val="1600"/>
-                        </a:lnSpc>
-                        <a:spcAft>
-                          <a:spcPts val="0"/>
-                        </a:spcAft>
-                        <a:defRPr sz="1200" b="0">
-                          <a:solidFill>
-                            <a:srgbClr val="21243A"/>
-                          </a:solidFill>
-                          <a:latin typeface="Arial"/>
-                        </a:defRPr>
-                      </a:pPr>
-                      <a:r>
-                        <a:t>Martin, S. (2026) SDA Vision: Synthetic-media Discourse Analysis (version 0.1.0)</a:t>
-                      </a:r>
-                    </a:p>
-                    <a:p>
-                      <a:pPr>
-                        <a:lnSpc>
-                          <a:spcPts val="1600"/>
-                        </a:lnSpc>
-                        <a:spcAft>
-                          <a:spcPts val="0"/>
-                        </a:spcAft>
-                        <a:defRPr sz="1200" b="0">
-                          <a:solidFill>
-                            <a:srgbClr val="21243A"/>
-                          </a:solidFill>
-                          <a:latin typeface="Arial"/>
-                        </a:defRPr>
-                      </a:pPr>
-                      <a:r>
-                        <a:t>[Computer software]. Manchester Metropolitan University. Available at:</a:t>
-                      </a:r>
-                    </a:p>
-                    <a:p>
-                      <a:pPr>
-                        <a:lnSpc>
-                          <a:spcPts val="1600"/>
-                        </a:lnSpc>
-                        <a:spcAft>
-                          <a:spcPts val="0"/>
-                        </a:spcAft>
-                        <a:defRPr sz="1200" b="0">
-                          <a:solidFill>
-                            <a:srgbClr val="21243A"/>
-                          </a:solidFill>
-                          <a:latin typeface="Arial"/>
-                        </a:defRPr>
-                      </a:pPr>
-                      <a:r>
-                        <a:t>https://sdavision.io/</a:t>
-                      </a:r>
-                    </a:p>
-                  </a:txBody>
-                  <a:tcPr marL="82296" marR="82296" marT="64008" marB="64008">
-                    <a:solidFill>
-                      <a:srgbClr val="F1F7F7"/>
-                    </a:solidFill>
-                  </a:tcPr>
-                </a:tc>
-              </a:tr>
-            </a:tbl>
-          </a:graphicData>
-        </a:graphic>
-      </p:graphicFrame>
-      <p:graphicFrame>
-        <p:nvGraphicFramePr>
-          <p:cNvPr id="8" name="Table 7"/>
-          <p:cNvGraphicFramePr>
-            <a:graphicFrameLocks noGrp="1"/>
-          </p:cNvGraphicFramePr>
-          <p:nvPr/>
-        </p:nvGraphicFramePr>
-        <p:xfrm>
-          <a:off x="365760" y="2456688"/>
-          <a:ext cx="8412479" cy="552704"/>
-        </p:xfrm>
-        <a:graphic>
-          <a:graphicData uri="http://schemas.openxmlformats.org/drawingml/2006/table">
-            <a:tbl>
-              <a:tblPr firstRow="1" bandRow="1">
-                <a:tableStyleId>{5C22544A-7EE6-4342-B048-85BDC9FD1C3A}</a:tableStyleId>
-              </a:tblPr>
-              <a:tblGrid>
-                <a:gridCol w="2271369"/>
-                <a:gridCol w="6141110"/>
-              </a:tblGrid>
-              <a:tr h="552704">
-                <a:tc>
-                  <a:txBody>
-                    <a:bodyPr wrap="none"/>
-                    <a:lstStyle/>
-                    <a:p>
-                      <a:pPr>
-                        <a:lnSpc>
-                          <a:spcPts val="1600"/>
-                        </a:lnSpc>
-                        <a:spcAft>
-                          <a:spcPts val="0"/>
-                        </a:spcAft>
-                        <a:defRPr sz="1200" b="0">
-                          <a:solidFill>
-                            <a:srgbClr val="21243A"/>
-                          </a:solidFill>
-                          <a:latin typeface="Arial"/>
-                        </a:defRPr>
-                      </a:pPr>
-                      <a:r>
-                        <a:t>Software creator</a:t>
-                      </a:r>
-                    </a:p>
-                  </a:txBody>
-                  <a:tcPr marL="82296" marR="82296" marT="64008" marB="64008">
-                    <a:solidFill>
-                      <a:srgbClr val="FFFFFF"/>
-                    </a:solidFill>
-                  </a:tcPr>
-                </a:tc>
-                <a:tc>
-                  <a:txBody>
-                    <a:bodyPr wrap="none"/>
-                    <a:lstStyle/>
-                    <a:p>
-                      <a:pPr>
-                        <a:lnSpc>
-                          <a:spcPts val="1600"/>
-                        </a:lnSpc>
-                        <a:spcAft>
-                          <a:spcPts val="0"/>
-                        </a:spcAft>
-                        <a:defRPr sz="1200" b="0">
-                          <a:solidFill>
-                            <a:srgbClr val="21243A"/>
-                          </a:solidFill>
-                          <a:latin typeface="Arial"/>
-                        </a:defRPr>
-                      </a:pPr>
-                      <a:r>
-                        <a:t>Dr Sam Martin, Smart Data Research UK (UKRI) Fellow, Manchester Metropolitan</a:t>
-                      </a:r>
-                    </a:p>
-                    <a:p>
-                      <a:pPr>
-                        <a:lnSpc>
-                          <a:spcPts val="1600"/>
-                        </a:lnSpc>
-                        <a:spcAft>
-                          <a:spcPts val="0"/>
-                        </a:spcAft>
-                        <a:defRPr sz="1200" b="0">
-                          <a:solidFill>
-                            <a:srgbClr val="21243A"/>
-                          </a:solidFill>
-                          <a:latin typeface="Arial"/>
-                        </a:defRPr>
-                      </a:pPr>
-                      <a:r>
-                        <a:t>University (MMU). ORCID: https://orcid.org/0000-0002-4466-8374.</a:t>
-                      </a:r>
-                    </a:p>
-                  </a:txBody>
-                  <a:tcPr marL="82296" marR="82296" marT="64008" marB="64008">
-                    <a:solidFill>
-                      <a:srgbClr val="FFFFFF"/>
-                    </a:solidFill>
-                  </a:tcPr>
-                </a:tc>
-              </a:tr>
-            </a:tbl>
-          </a:graphicData>
-        </a:graphic>
-      </p:graphicFrame>
-      <p:graphicFrame>
-        <p:nvGraphicFramePr>
-          <p:cNvPr id="9" name="Table 8"/>
-          <p:cNvGraphicFramePr>
-            <a:graphicFrameLocks noGrp="1"/>
-          </p:cNvGraphicFramePr>
-          <p:nvPr/>
-        </p:nvGraphicFramePr>
-        <p:xfrm>
-          <a:off x="365760" y="3009392"/>
-          <a:ext cx="8412479" cy="552704"/>
-        </p:xfrm>
-        <a:graphic>
-          <a:graphicData uri="http://schemas.openxmlformats.org/drawingml/2006/table">
-            <a:tbl>
-              <a:tblPr firstRow="1" bandRow="1">
-                <a:tableStyleId>{5C22544A-7EE6-4342-B048-85BDC9FD1C3A}</a:tableStyleId>
-              </a:tblPr>
-              <a:tblGrid>
-                <a:gridCol w="2271369"/>
-                <a:gridCol w="6141110"/>
-              </a:tblGrid>
-              <a:tr h="552704">
-                <a:tc>
-                  <a:txBody>
-                    <a:bodyPr wrap="none"/>
-                    <a:lstStyle/>
-                    <a:p>
-                      <a:pPr>
-                        <a:lnSpc>
-                          <a:spcPts val="1600"/>
-                        </a:lnSpc>
-                        <a:spcAft>
-                          <a:spcPts val="0"/>
-                        </a:spcAft>
-                        <a:defRPr sz="1200" b="0">
-                          <a:solidFill>
-                            <a:srgbClr val="21243A"/>
-                          </a:solidFill>
-                          <a:latin typeface="Arial"/>
-                        </a:defRPr>
-                      </a:pPr>
-                      <a:r>
-                        <a:t>Funding acknowledgement</a:t>
-                      </a:r>
-                    </a:p>
-                  </a:txBody>
-                  <a:tcPr marL="82296" marR="82296" marT="64008" marB="64008">
-                    <a:solidFill>
-                      <a:srgbClr val="F1F7F7"/>
-                    </a:solidFill>
-                  </a:tcPr>
-                </a:tc>
-                <a:tc>
-                  <a:txBody>
-                    <a:bodyPr wrap="none"/>
-                    <a:lstStyle/>
-                    <a:p>
-                      <a:pPr>
-                        <a:lnSpc>
-                          <a:spcPts val="1600"/>
-                        </a:lnSpc>
-                        <a:spcAft>
-                          <a:spcPts val="0"/>
-                        </a:spcAft>
-                        <a:defRPr sz="1200" b="0">
-                          <a:solidFill>
-                            <a:srgbClr val="21243A"/>
-                          </a:solidFill>
-                          <a:latin typeface="Arial"/>
-                        </a:defRPr>
-                      </a:pPr>
-                      <a:r>
-                        <a:t>This work was supported by Smart Data Research UK, a UKRI investment; Grant</a:t>
-                      </a:r>
-                    </a:p>
-                    <a:p>
-                      <a:pPr>
-                        <a:lnSpc>
-                          <a:spcPts val="1600"/>
-                        </a:lnSpc>
-                        <a:spcAft>
-                          <a:spcPts val="0"/>
-                        </a:spcAft>
-                        <a:defRPr sz="1200" b="0">
-                          <a:solidFill>
-                            <a:srgbClr val="21243A"/>
-                          </a:solidFill>
-                          <a:latin typeface="Arial"/>
-                        </a:defRPr>
-                      </a:pPr>
-                      <a:r>
-                        <a:t>number UKRI4010.</a:t>
-                      </a:r>
-                    </a:p>
-                  </a:txBody>
-                  <a:tcPr marL="82296" marR="82296" marT="64008" marB="64008">
-                    <a:solidFill>
-                      <a:srgbClr val="F1F7F7"/>
-                    </a:solidFill>
-                  </a:tcPr>
-                </a:tc>
-              </a:tr>
-            </a:tbl>
-          </a:graphicData>
-        </a:graphic>
-      </p:graphicFrame>
-      <p:graphicFrame>
-        <p:nvGraphicFramePr>
-          <p:cNvPr id="10" name="Table 9"/>
-          <p:cNvGraphicFramePr>
-            <a:graphicFrameLocks noGrp="1"/>
-          </p:cNvGraphicFramePr>
-          <p:nvPr/>
-        </p:nvGraphicFramePr>
-        <p:xfrm>
-          <a:off x="365760" y="3562095"/>
-          <a:ext cx="8412479" cy="755904"/>
-        </p:xfrm>
-        <a:graphic>
-          <a:graphicData uri="http://schemas.openxmlformats.org/drawingml/2006/table">
-            <a:tbl>
-              <a:tblPr firstRow="1" bandRow="1">
-                <a:tableStyleId>{5C22544A-7EE6-4342-B048-85BDC9FD1C3A}</a:tableStyleId>
-              </a:tblPr>
-              <a:tblGrid>
-                <a:gridCol w="2271369"/>
-                <a:gridCol w="6141110"/>
-              </a:tblGrid>
-              <a:tr h="755904">
-                <a:tc>
-                  <a:txBody>
-                    <a:bodyPr wrap="none"/>
-                    <a:lstStyle/>
-                    <a:p>
-                      <a:pPr>
-                        <a:lnSpc>
-                          <a:spcPts val="1600"/>
-                        </a:lnSpc>
-                        <a:spcAft>
-                          <a:spcPts val="0"/>
-                        </a:spcAft>
-                        <a:defRPr sz="1200" b="0">
-                          <a:solidFill>
-                            <a:srgbClr val="21243A"/>
-                          </a:solidFill>
-                          <a:latin typeface="Arial"/>
-                        </a:defRPr>
-                      </a:pPr>
-                      <a:r>
-                        <a:t>Analysis record</a:t>
-                      </a:r>
-                    </a:p>
-                  </a:txBody>
-                  <a:tcPr marL="82296" marR="82296" marT="64008" marB="64008">
-                    <a:solidFill>
-                      <a:srgbClr val="FFFFFF"/>
-                    </a:solidFill>
-                  </a:tcPr>
-                </a:tc>
-                <a:tc>
-                  <a:txBody>
-                    <a:bodyPr wrap="none"/>
-                    <a:lstStyle/>
-                    <a:p>
-                      <a:pPr>
-                        <a:lnSpc>
-                          <a:spcPts val="1600"/>
-                        </a:lnSpc>
-                        <a:spcAft>
-                          <a:spcPts val="0"/>
-                        </a:spcAft>
-                        <a:defRPr sz="1200" b="0">
-                          <a:solidFill>
-                            <a:srgbClr val="21243A"/>
-                          </a:solidFill>
-                          <a:latin typeface="Arial"/>
-                        </a:defRPr>
-                      </a:pPr>
-                      <a:r>
-                        <a:t>File: animal-portrait.jpg; media type: image; recorded at:</a:t>
-                      </a:r>
-                    </a:p>
-                    <a:p>
-                      <a:pPr>
-                        <a:lnSpc>
-                          <a:spcPts val="1600"/>
-                        </a:lnSpc>
-                        <a:spcAft>
-                          <a:spcPts val="0"/>
-                        </a:spcAft>
-                        <a:defRPr sz="1200" b="0">
-                          <a:solidFill>
-                            <a:srgbClr val="21243A"/>
-                          </a:solidFill>
-                          <a:latin typeface="Arial"/>
-                        </a:defRPr>
-                      </a:pPr>
-                      <a:r>
-                        <a:t>2026-09-26T22:31:02+00:00; models: claude-opus-5-5, gemini-3.8-flash,</a:t>
-                      </a:r>
-                    </a:p>
-                    <a:p>
-                      <a:pPr>
-                        <a:lnSpc>
-                          <a:spcPts val="1600"/>
-                        </a:lnSpc>
-                        <a:spcAft>
-                          <a:spcPts val="0"/>
-                        </a:spcAft>
-                        <a:defRPr sz="1200" b="0">
-                          <a:solidFill>
-                            <a:srgbClr val="21243A"/>
-                          </a:solidFill>
-                          <a:latin typeface="Arial"/>
-                        </a:defRPr>
-                      </a:pPr>
-                      <a:r>
-                        <a:t>gpt-6-astra.</a:t>
-                      </a:r>
-                    </a:p>
-                  </a:txBody>
-                  <a:tcPr marL="82296" marR="82296" marT="64008" marB="64008">
-                    <a:solidFill>
-                      <a:srgbClr val="FFFFFF"/>
-                    </a:solidFill>
-                  </a:tcPr>
-                </a:tc>
-              </a:tr>
-            </a:tbl>
-          </a:graphicData>
-        </a:graphic>
-      </p:graphicFrame>
-    </p:spTree>
-  </p:cSld>
-  <p:clrMapOvr>
-    <a:masterClrMapping/>
-  </p:clrMapOvr>
-</p:sld>
-</file>
-
-<file path=ppt/slides/slide19.xml><?xml version="1.0" encoding="utf-8"?>
-<p:sld xmlns:a="http://schemas.openxmlformats.org/drawingml/2006/main" xmlns:p="http://schemas.openxmlformats.org/presentationml/2006/main" xmlns:r="http://schemas.openxmlformats.org/officeDocument/2006/relationships">
-  <p:cSld>
-    <p:spTree>
-      <p:nvGrpSpPr>
-        <p:cNvPr id="1" name=""/>
-        <p:cNvGrpSpPr/>
-        <p:nvPr/>
-      </p:nvGrpSpPr>
-      <p:grpSpPr/>
-      <p:sp>
-        <p:nvSpPr>
-          <p:cNvPr id="2" name="TextBox 1"/>
-          <p:cNvSpPr txBox="1"/>
-          <p:nvPr/>
-        </p:nvSpPr>
-        <p:spPr>
-          <a:xfrm>
-            <a:off x="365760" y="219456"/>
-            <a:ext cx="8412480" cy="228600"/>
-          </a:xfrm>
-          <a:prstGeom prst="rect">
-            <a:avLst/>
-          </a:prstGeom>
-          <a:noFill/>
-        </p:spPr>
-        <p:txBody>
-          <a:bodyPr wrap="square" lIns="0" rIns="0" tIns="0" bIns="0">
-            <a:spAutoFit/>
-          </a:bodyPr>
-          <a:lstStyle/>
-          <a:p>
-            <a:pPr>
-              <a:lnSpc>
-                <a:spcPct val="115000"/>
-              </a:lnSpc>
-              <a:spcAft>
-                <a:spcPts val="0"/>
-              </a:spcAft>
-              <a:defRPr sz="1100" b="1">
-                <a:solidFill>
-                  <a:srgbClr val="C5006A"/>
-                </a:solidFill>
-                <a:latin typeface="Arial"/>
-              </a:defRPr>
-            </a:pPr>
-            <a:r>
-              <a:t>SDA VISION / RESEARCH REPORT</a:t>
-            </a:r>
-          </a:p>
-        </p:txBody>
-      </p:sp>
-      <p:sp>
-        <p:nvSpPr>
-          <p:cNvPr id="3" name="TextBox 2"/>
-          <p:cNvSpPr txBox="1"/>
-          <p:nvPr/>
-        </p:nvSpPr>
-        <p:spPr>
-          <a:xfrm>
-            <a:off x="365760" y="658368"/>
-            <a:ext cx="8412480" cy="612648"/>
-          </a:xfrm>
-          <a:prstGeom prst="rect">
-            <a:avLst/>
-          </a:prstGeom>
-          <a:noFill/>
-        </p:spPr>
-        <p:txBody>
-          <a:bodyPr wrap="square" lIns="0" rIns="0" tIns="0" bIns="0">
-            <a:spAutoFit/>
-          </a:bodyPr>
-          <a:lstStyle/>
-          <a:p>
-            <a:pPr>
-              <a:lnSpc>
-                <a:spcPct val="115000"/>
-              </a:lnSpc>
-              <a:spcAft>
-                <a:spcPts val="0"/>
-              </a:spcAft>
-              <a:defRPr sz="2200" b="1">
-                <a:solidFill>
-                  <a:srgbClr val="21243A"/>
-                </a:solidFill>
-                <a:latin typeface="Arial"/>
-              </a:defRPr>
-            </a:pPr>
-            <a:r>
-              <a:t>File and analysis record</a:t>
-            </a:r>
-          </a:p>
-        </p:txBody>
-      </p:sp>
-      <p:sp>
-        <p:nvSpPr>
-          <p:cNvPr id="4" name="TextBox 3"/>
-          <p:cNvSpPr txBox="1"/>
-          <p:nvPr/>
-        </p:nvSpPr>
-        <p:spPr>
-          <a:xfrm>
-            <a:off x="365760" y="6291072"/>
-            <a:ext cx="8001000" cy="365760"/>
-          </a:xfrm>
-          <a:prstGeom prst="rect">
-            <a:avLst/>
-          </a:prstGeom>
-          <a:noFill/>
-        </p:spPr>
-        <p:txBody>
-          <a:bodyPr wrap="square" lIns="0" rIns="0" tIns="0" bIns="0">
-            <a:spAutoFit/>
-          </a:bodyPr>
-          <a:lstStyle/>
-          <a:p>
-            <a:pPr>
-              <a:lnSpc>
-                <a:spcPct val="115000"/>
-              </a:lnSpc>
-              <a:spcAft>
-                <a:spcPts val="0"/>
-              </a:spcAft>
-              <a:defRPr sz="800" b="0">
-                <a:solidFill>
-                  <a:srgbClr val="545B6D"/>
-                </a:solidFill>
-                <a:latin typeface="Arial"/>
-              </a:defRPr>
-            </a:pPr>
-            <a:r>
-              <a:t>Research assessment. Ratings are not calibrated probabilities.</a:t>
-            </a:r>
-          </a:p>
-        </p:txBody>
-      </p:sp>
-      <p:sp>
-        <p:nvSpPr>
-          <p:cNvPr id="5" name="TextBox 4"/>
-          <p:cNvSpPr txBox="1"/>
-          <p:nvPr/>
-        </p:nvSpPr>
-        <p:spPr>
-          <a:xfrm>
-            <a:off x="8394192" y="6318504"/>
-            <a:ext cx="365760" cy="228600"/>
-          </a:xfrm>
-          <a:prstGeom prst="rect">
-            <a:avLst/>
-          </a:prstGeom>
-          <a:noFill/>
-        </p:spPr>
-        <p:txBody>
-          <a:bodyPr wrap="square" lIns="0" rIns="0" tIns="0" bIns="0">
-            <a:spAutoFit/>
-          </a:bodyPr>
-          <a:lstStyle/>
-          <a:p>
-            <a:pPr>
-              <a:lnSpc>
-                <a:spcPct val="115000"/>
-              </a:lnSpc>
-              <a:spcAft>
-                <a:spcPts val="0"/>
-              </a:spcAft>
-              <a:defRPr sz="900" b="0">
-                <a:solidFill>
-                  <a:srgbClr val="545B6D"/>
-                </a:solidFill>
-                <a:latin typeface="Arial"/>
-              </a:defRPr>
-            </a:pPr>
-            <a:r>
-              <a:t>19</a:t>
             </a:r>
           </a:p>
         </p:txBody>

</xml_diff>